<commit_message>
Revise deck: foreground Phase-2 judging criteria; de-personalize; tighten
- Add a capstone "Built for the four Phase-2 judging criteria" slide mapping
  the dataset to NCATS's confidence factors (ability to solve · potential
  impact · feasibility & rigor · transparency & reproducibility), with the
  concrete evidence for each and a CC-BY/FAIR/NIH-data-sharing line.
- Sharpen the impact framing up front: most public oligo-tox data is hepatic;
  kidney is under-served, and the set is built for in-silico modeling.
- Remove the standalone Roadmap slide (its status/next-steps are covered by
  the scorecard and the ask) to keep the deck concise; net slide count holds.
- Replace all references to the reviewer's name with "biochemistry expert"
  across slides and speaker notes.

Regenerate PPTX (notes in Notes pane) and PDF from the revised deck.

Co-Authored-By: Claude Opus 4.8 <noreply@anthropic.com>
Claude-Session: https://claude.ai/code/session_01JgcYx68nEBxtB9JCiy79aK
</commit_message>
<xml_diff>
--- a/OligoTox-Kidney.pptx
+++ b/OligoTox-Kidney.pptx
@@ -538,7 +538,7 @@
 • "Nephrotoxicity" = kidney toxicity (nephro = kidney).
 • "Per-measurement" = each row is one experimental result, the finest detail.
 • "NCATS Phase 2" = the data-generation phase of the challenge; it scores DATASETS.
-This deck is for German to review the science and sign off the toxicity grades.</a:t>
+This deck is for a biochemistry expert to review the science and sign off the grades.</a:t>
             </a:r>
             <a:endParaRPr lang="en-US" dirty="0"/>
           </a:p>
@@ -730,8 +730,8 @@
     filter units), or kidney failure.
 "Ordinal" = ranked (0&lt;1&lt;2&lt;3) but gaps aren't necessarily equal. "Rubric" = the
 written rulebook for assigning grades. "Anchor" = a famous example that pins each
-level (inotersen for severe, etc.). Every grade is PROVISIONAL until an expert
-(German) confirms it.</a:t>
+level (inotersen for severe, etc.). Every grade is PROVISIONAL until a biochemistry
+expert confirms it.</a:t>
             </a:r>
             <a:endParaRPr lang="en-US" dirty="0"/>
           </a:p>
@@ -2040,6 +2040,109 @@
             <a:r>
               <a:rPr lang="en-US" dirty="0"/>
               <a:t>SPEAKER NOTES — plain English
+NCATS scores Phase 2 on four "confidence factors"; this slide maps our work to each:
+1. Ability to solve — is the data useful for building computer models that PREDICT
+   oligo toxicity? Our design pairs each drug's sequence/chemistry with a graded
+   kidney outcome — exactly what such a model needs.
+2. Potential impact — does it fill a public gap? Most existing open oligo-tox data
+   is about the LIVER; kidney data is scarce. Ours is the first open set linking
+   oligo design to graded KIDNEY toxicity, including the easily-missed functional
+   injury.
+3. Feasibility &amp; rigor — would researchers trust it? Yes: nothing fabricated, every
+   row sourced, controlled vocabulary, automated quality checks all passing.
+4. Transparency &amp; reproducibility — is it open and re-checkable? Intended CC-BY open
+   license; every value traces to its source; all the numbers regenerate from the
+   data files. "FAIR" = Findable, Accessible, Interoperable, Reusable — the standard
+   for good scientific data that NIH's data-sharing policy expects.
+We designed for these four from the start, rather than fitting them afterward.</a:t>
+            </a:r>
+            <a:endParaRPr lang="en-US" dirty="0"/>
+          </a:p>
+        </p:txBody>
+      </p:sp>
+      <p:sp>
+        <p:nvSpPr>
+          <p:cNvPr id="4" name="Slide Number Placeholder 3"/>
+          <p:cNvSpPr>
+            <a:spLocks noGrp="1"/>
+          </p:cNvSpPr>
+          <p:nvPr>
+            <p:ph type="sldNum" sz="quarter" idx="10"/>
+          </p:nvPr>
+        </p:nvSpPr>
+        <p:spPr/>
+        <p:txBody>
+          <a:bodyPr/>
+          <a:lstStyle/>
+          <a:p>
+            <a:fld id="{F7021451-1387-4CA6-816F-3879F97B5CBC}" type="slidenum">
+              <a:rPr lang="en-US"/>
+              <a:t>24</a:t>
+            </a:fld>
+            <a:endParaRPr lang="en-US"/>
+          </a:p>
+        </p:txBody>
+      </p:sp>
+    </p:spTree>
+    <p:extLst>
+      <p:ext uri="{BB962C8B-B14F-4D97-AF65-F5344CB8AC3E}">
+        <p14:creationId xmlns:p14="http://schemas.microsoft.com/office/powerpoint/2010/main" val="1024086991"/>
+      </p:ext>
+    </p:extLst>
+  </p:cSld>
+  <p:clrMapOvr>
+    <a:masterClrMapping/>
+  </p:clrMapOvr>
+</p:notes>
+</file>
+
+<file path=ppt/notesSlides/notesSlide25.xml><?xml version="1.0" encoding="utf-8"?>
+<p:notes xmlns:a="http://schemas.openxmlformats.org/drawingml/2006/main" xmlns:r="http://schemas.openxmlformats.org/officeDocument/2006/relationships" xmlns:p="http://schemas.openxmlformats.org/presentationml/2006/main">
+  <p:cSld>
+    <p:spTree>
+      <p:nvGrpSpPr>
+        <p:cNvPr id="1" name=""/>
+        <p:cNvGrpSpPr/>
+        <p:nvPr/>
+      </p:nvGrpSpPr>
+      <p:grpSpPr>
+        <a:xfrm>
+          <a:off x="0" y="0"/>
+          <a:ext cx="0" cy="0"/>
+          <a:chOff x="0" y="0"/>
+          <a:chExt cx="0" cy="0"/>
+        </a:xfrm>
+      </p:grpSpPr>
+      <p:sp>
+        <p:nvSpPr>
+          <p:cNvPr id="2" name="Slide Image Placeholder 1"/>
+          <p:cNvSpPr>
+            <a:spLocks noGrp="1" noRot="1" noChangeAspect="1"/>
+          </p:cNvSpPr>
+          <p:nvPr>
+            <p:ph type="sldImg"/>
+          </p:nvPr>
+        </p:nvSpPr>
+        <p:spPr/>
+      </p:sp>
+      <p:sp>
+        <p:nvSpPr>
+          <p:cNvPr id="3" name="Notes Placeholder 2"/>
+          <p:cNvSpPr>
+            <a:spLocks noGrp="1"/>
+          </p:cNvSpPr>
+          <p:nvPr>
+            <p:ph type="body" idx="1"/>
+          </p:nvPr>
+        </p:nvSpPr>
+        <p:spPr/>
+        <p:txBody>
+          <a:bodyPr/>
+          <a:lstStyle/>
+          <a:p>
+            <a:r>
+              <a:rPr lang="en-US" dirty="0"/>
+              <a:t>SPEAKER NOTES — plain English
 Two trust pillars. PROVENANCE = the documented origin of each value: which source,
 which exact table/figure, and whether we're legally allowed to republish it
 ("public domain" = yes, e.g. patents and government labels; "summary stat" = we
@@ -2069,7 +2172,7 @@
           <a:p>
             <a:fld id="{F7021451-1387-4CA6-816F-3879F97B5CBC}" type="slidenum">
               <a:rPr lang="en-US"/>
-              <a:t>24</a:t>
+              <a:t>25</a:t>
             </a:fld>
             <a:endParaRPr lang="en-US"/>
           </a:p>
@@ -2088,7 +2191,7 @@
 </p:notes>
 </file>
 
-<file path=ppt/notesSlides/notesSlide25.xml><?xml version="1.0" encoding="utf-8"?>
+<file path=ppt/notesSlides/notesSlide26.xml><?xml version="1.0" encoding="utf-8"?>
 <p:notes xmlns:a="http://schemas.openxmlformats.org/drawingml/2006/main" xmlns:r="http://schemas.openxmlformats.org/officeDocument/2006/relationships" xmlns:p="http://schemas.openxmlformats.org/presentationml/2006/main">
   <p:cSld>
     <p:spTree>
@@ -2162,7 +2265,7 @@
           <a:p>
             <a:fld id="{F7021451-1387-4CA6-816F-3879F97B5CBC}" type="slidenum">
               <a:rPr lang="en-US"/>
-              <a:t>25</a:t>
+              <a:t>26</a:t>
             </a:fld>
             <a:endParaRPr lang="en-US"/>
           </a:p>
@@ -2181,7 +2284,7 @@
 </p:notes>
 </file>
 
-<file path=ppt/notesSlides/notesSlide26.xml><?xml version="1.0" encoding="utf-8"?>
+<file path=ppt/notesSlides/notesSlide27.xml><?xml version="1.0" encoding="utf-8"?>
 <p:notes xmlns:a="http://schemas.openxmlformats.org/drawingml/2006/main" xmlns:r="http://schemas.openxmlformats.org/officeDocument/2006/relationships" xmlns:p="http://schemas.openxmlformats.org/presentationml/2006/main">
   <p:cSld>
     <p:spTree>
@@ -2230,11 +2333,11 @@
               <a:t>SPEAKER NOTES — plain English
 The concrete ask. (1) The big one: review our 0–3 grades against the rulebook and
 confirm/correct them — focus on the 2-vs-3 boundary and whether we converted the
-patent's word-ratings correctly; his OK lets us finalise the grades. (2) Sanity-
-check the core biology story. (3) Point out any source he'd want re-verified,
-especially the web-summary rows. Everything else (the written narrative, WS
-verification, more sequences, a second patent) is paused until he weighs in, so we
-don't polish things he might change.</a:t>
+patent's word-ratings correctly; their sign-off lets us finalise the grades. (2)
+Sanity-check the core biology story. (3) Point out any source they'd want
+re-verified, especially the web-summary rows. Everything else (the written
+narrative, WS verification, more sequences, a second patent) is paused until they
+weigh in, so we don't polish things that might change.</a:t>
             </a:r>
             <a:endParaRPr lang="en-US" dirty="0"/>
           </a:p>
@@ -2257,7 +2360,7 @@
           <a:p>
             <a:fld id="{F7021451-1387-4CA6-816F-3879F97B5CBC}" type="slidenum">
               <a:rPr lang="en-US"/>
-              <a:t>26</a:t>
+              <a:t>27</a:t>
             </a:fld>
             <a:endParaRPr lang="en-US"/>
           </a:p>
@@ -2276,7 +2379,7 @@
 </p:notes>
 </file>
 
-<file path=ppt/notesSlides/notesSlide27.xml><?xml version="1.0" encoding="utf-8"?>
+<file path=ppt/notesSlides/notesSlide28.xml><?xml version="1.0" encoding="utf-8"?>
 <p:notes xmlns:a="http://schemas.openxmlformats.org/drawingml/2006/main" xmlns:r="http://schemas.openxmlformats.org/officeDocument/2006/relationships" xmlns:p="http://schemas.openxmlformats.org/presentationml/2006/main">
   <p:cSld>
     <p:spTree>
@@ -2323,100 +2426,9 @@
             <a:r>
               <a:rPr lang="en-US" dirty="0"/>
               <a:t>SPEAKER NOTES — plain English
-Where we are and what's left. The dataset already meets the size and coverage
-goals with full documentation. The remaining work is mostly checking (grade
-sign-off, verifying the web-sourced rows) and writing the required narrative, plus
-optional extra volume from a second patent. Submission runs May–Dec 2026.</a:t>
-            </a:r>
-            <a:endParaRPr lang="en-US" dirty="0"/>
-          </a:p>
-        </p:txBody>
-      </p:sp>
-      <p:sp>
-        <p:nvSpPr>
-          <p:cNvPr id="4" name="Slide Number Placeholder 3"/>
-          <p:cNvSpPr>
-            <a:spLocks noGrp="1"/>
-          </p:cNvSpPr>
-          <p:nvPr>
-            <p:ph type="sldNum" sz="quarter" idx="10"/>
-          </p:nvPr>
-        </p:nvSpPr>
-        <p:spPr/>
-        <p:txBody>
-          <a:bodyPr/>
-          <a:lstStyle/>
-          <a:p>
-            <a:fld id="{F7021451-1387-4CA6-816F-3879F97B5CBC}" type="slidenum">
-              <a:rPr lang="en-US"/>
-              <a:t>27</a:t>
-            </a:fld>
-            <a:endParaRPr lang="en-US"/>
-          </a:p>
-        </p:txBody>
-      </p:sp>
-    </p:spTree>
-    <p:extLst>
-      <p:ext uri="{BB962C8B-B14F-4D97-AF65-F5344CB8AC3E}">
-        <p14:creationId xmlns:p14="http://schemas.microsoft.com/office/powerpoint/2010/main" val="1024086991"/>
-      </p:ext>
-    </p:extLst>
-  </p:cSld>
-  <p:clrMapOvr>
-    <a:masterClrMapping/>
-  </p:clrMapOvr>
-</p:notes>
-</file>
-
-<file path=ppt/notesSlides/notesSlide28.xml><?xml version="1.0" encoding="utf-8"?>
-<p:notes xmlns:a="http://schemas.openxmlformats.org/drawingml/2006/main" xmlns:r="http://schemas.openxmlformats.org/officeDocument/2006/relationships" xmlns:p="http://schemas.openxmlformats.org/presentationml/2006/main">
-  <p:cSld>
-    <p:spTree>
-      <p:nvGrpSpPr>
-        <p:cNvPr id="1" name=""/>
-        <p:cNvGrpSpPr/>
-        <p:nvPr/>
-      </p:nvGrpSpPr>
-      <p:grpSpPr>
-        <a:xfrm>
-          <a:off x="0" y="0"/>
-          <a:ext cx="0" cy="0"/>
-          <a:chOff x="0" y="0"/>
-          <a:chExt cx="0" cy="0"/>
-        </a:xfrm>
-      </p:grpSpPr>
-      <p:sp>
-        <p:nvSpPr>
-          <p:cNvPr id="2" name="Slide Image Placeholder 1"/>
-          <p:cNvSpPr>
-            <a:spLocks noGrp="1" noRot="1" noChangeAspect="1"/>
-          </p:cNvSpPr>
-          <p:nvPr>
-            <p:ph type="sldImg"/>
-          </p:nvPr>
-        </p:nvSpPr>
-        <p:spPr/>
-      </p:sp>
-      <p:sp>
-        <p:nvSpPr>
-          <p:cNvPr id="3" name="Notes Placeholder 2"/>
-          <p:cNvSpPr>
-            <a:spLocks noGrp="1"/>
-          </p:cNvSpPr>
-          <p:nvPr>
-            <p:ph type="body" idx="1"/>
-          </p:nvPr>
-        </p:nvSpPr>
-        <p:spPr/>
-        <p:txBody>
-          <a:bodyPr/>
-          <a:lstStyle/>
-          <a:p>
-            <a:r>
-              <a:rPr lang="en-US" dirty="0"/>
-              <a:t>SPEAKER NOTES — plain English
-A map of the project folder so German knows where to look. The key file for his
-review is data/measurements.csv (the graded results); the rulebook is schema.md.
+A map of the project folder so the biochemistry expert knows where to look. The key
+file for review is data/measurements.csv (the graded results); the rulebook is
+schema.md.
 Closing point: every count on these slides comes straight out of the data files,
 so the deck can't drift from the underlying data. We'd love comments on specific
 rows, not just general impressions.</a:t>
@@ -2512,8 +2524,10 @@
 is especially exposed because it filters the blood and concentrates whatever
 passes through, so these drugs pile up there. Several have caused real kidney
 problems. "Proteinuria" = protein leaking into urine, a classic kidney-trouble
-sign. The missing piece in the field is a tidy table linking each drug's design
-to a kidney-toxicity score — that is our contribution.</a:t>
+sign. Most existing open oligo-tox data is about the LIVER; kidney is under-served
+— so an open kidney set fills a real public gap (Phase 2's "potential impact").
+The missing piece is a tidy table linking each drug's design to a kidney-toxicity
+score, ready for an in-silico model — that is our contribution.</a:t>
             </a:r>
             <a:endParaRPr lang="en-US" dirty="0"/>
           </a:p>

</xml_diff>